<commit_message>
refactor: complete project-wide rebranding to SevZero across all code, configs, helm charts, and screenshots
</commit_message>
<xml_diff>
--- a/demo/SevZero_Capstone_Presentation_v2.pptx
+++ b/demo/SevZero_Capstone_Presentation_v2.pptx
@@ -4960,7 +4960,7 @@
         │
 Pod: ErrImagePull / ImagePullBackOff
         │
-        ▼  kubectl describe pod -n opspulse
+        ▼  kubectl describe pod -n sevzero
 Root Cause: Registry tag not found
         │
         ▼  FIX: use verified GHCR SHA
@@ -4971,10 +4971,10 @@
         │
 Service exists  →  curl: Connection Refused
         │
-        ▼  kubectl get endpoints -n opspulse
+        ▼  kubectl get endpoints -n sevzero
 Root Cause: Endpoints = &lt;none&gt;  (mismatch)
         │
-        ▼  FIX: selector  app: opspulse-backend
+        ▼  FIX: selector  app: sevzero-backend
 Endpoints populated  →  Traffic flows ✓</a:t>
             </a:r>
           </a:p>
@@ -6779,7 +6779,7 @@
 │  helm upgrade --install ──► K8s Rolling Update               │
 │         │                                                     │
 │  ┌──────▼──────────────────────────────────────────┐         │
-│  │   AWS EKS Cluster  (Helm 3 / opspulse ns)       │         │
+│  │   AWS EKS Cluster  (Helm 3 / sevzero ns)       │         │
 │  │   Backend ×2  │  Frontend ×2  │  HPA (2→6)      │         │
 │  └──────┬──────────────────────────────────────────┘         │
 │         │                                                     │
@@ -9741,7 +9741,7 @@
        │
   ┌────┴─────────────────────────────────────┐
   │  STAGE 3 — DEPLOY                 (5s)   │
-  │  helm upgrade --install opspulse         │
+  │  helm upgrade --install sevzero         │
   │  K8s Rolling Update (zero downtime)      │
   └──────────────────────────────────────────┘</a:t>
             </a:r>
@@ -12328,7 +12328,7 @@
                 </a:solidFill>
                 <a:latin typeface="Courier New"/>
               </a:rPr>
-              <a:t>[ opspulse.local ] ──► [ Nginx Ingress ]
+              <a:t>[ sevzero.local ] ──► [ Nginx Ingress ]
                                  │
            ┌─────────────────────┴──────────────────┐
            │ Path: /                   Path: /api    │
@@ -12341,11 +12341,11 @@
                                        │
                             [ PostgreSQL Pod ×1    ]
                             [ PVC: 1Gi ReadWriteOnce ]
-NAMESPACE: opspulse
+NAMESPACE: sevzero
 ════════════════════
 ├── Deployments:  backend · frontend · postgres
 ├── Services:     ClusterIP  :80  :8000  :5432
-├── Ingress:      opspulse.local routing
+├── Ingress:      sevzero.local routing
 └── HPA:          CPU 75%  →  2 to 6 pods</a:t>
             </a:r>
           </a:p>
@@ -12606,7 +12606,7 @@
                 </a:solidFill>
                 <a:latin typeface="Inter"/>
               </a:rPr>
-              <a:t>opspulse — dedicated isolation</a:t>
+              <a:t>sevzero — dedicated isolation</a:t>
             </a:r>
           </a:p>
         </p:txBody>
@@ -12816,7 +12816,7 @@
                 </a:solidFill>
                 <a:latin typeface="Inter"/>
               </a:rPr>
-              <a:t>opspulse.local host routing</a:t>
+              <a:t>sevzero.local host routing</a:t>
             </a:r>
           </a:p>
         </p:txBody>
@@ -13330,7 +13330,7 @@
 Prometheus Operator
 ──────────────────────
 Targets: 2/2  STATUS: UP ✓
-Labels: namespace=opspulse  job=backend
+Labels: namespace=sevzero  job=backend
         │
         │  PromQL queries
         ▼

</xml_diff>